<commit_message>
Quiz deck: dark theme (#172849 background, #FBFAF4 text)
Builder colour roles are now switchable per deck with "theme": "dark";
lecture decks keep the light theme.

Co-Authored-By: Claude Opus 5.5 <noreply@anthropic.com>
Claude-Session: https://claude.ai/code/session_01Nw7HpGarY4JnDFYKKuarvZ
</commit_message>
<xml_diff>
--- a/mkt1107/output/MKT1107_KiemTra_TracNghiem_Bai1-7.pptx
+++ b/mkt1107/output/MKT1107_KiemTra_TracNghiem_Bai1-7.pptx
@@ -120,7 +120,7 @@
   <p:extLst>
     <p:ext uri="{521415D9-36F7-43E2-AB2F-B90AF26B5E84}">
       <p14:sectionLst xmlns:p14="http://schemas.microsoft.com/office/powerpoint/2010/main">
-        <p14:section name="Mở đầu" id="{84339815-6aa8-3258-6c13-4705dc5f39a7}">
+        <p14:section name="Mở đầu" id="{4b4ee02a-b01d-ca74-0d7c-631069c0fcd4}">
           <p14:sldIdLst>
             <p14:sldId id="256"/>
             <p14:sldId id="257"/>
@@ -1764,7 +1764,7 @@
     <p:bg>
       <p:bgPr>
         <a:solidFill>
-          <a:srgbClr val="FBFAF4"/>
+          <a:srgbClr val="172849"/>
         </a:solidFill>
       </p:bgPr>
     </p:bg>
@@ -1796,7 +1796,7 @@
     <p:bg>
       <p:bgPr>
         <a:solidFill>
-          <a:srgbClr val="FBFAF4"/>
+          <a:srgbClr val="172849"/>
         </a:solidFill>
       </p:bgPr>
     </p:bg>
@@ -1840,7 +1840,7 @@
               <a:buNone/>
               <a:defRPr lang="en-US" b="1" dirty="0">
                 <a:solidFill>
-                  <a:srgbClr val="2E2A3A"/>
+                  <a:srgbClr val="FBFAF4"/>
                 </a:solidFill>
                 <a:latin typeface="Alexandria" pitchFamily="34" charset="0"/>
                 <a:ea typeface="Alexandria" pitchFamily="34" charset="-122"/>
@@ -1886,7 +1886,7 @@
             <a:lvl1pPr>
               <a:defRPr sz="2400">
                 <a:solidFill>
-                  <a:srgbClr val="5B5668"/>
+                  <a:srgbClr val="C9CDD8"/>
                 </a:solidFill>
                 <a:latin typeface="Alexandria"/>
                 <a:ea typeface="Alexandria"/>
@@ -1918,7 +1918,7 @@
     <p:bg>
       <p:bgPr>
         <a:solidFill>
-          <a:srgbClr val="FBFAF4"/>
+          <a:srgbClr val="172849"/>
         </a:solidFill>
       </p:bgPr>
     </p:bg>
@@ -1962,7 +1962,7 @@
               <a:buNone/>
               <a:defRPr lang="en-US" b="1" dirty="0">
                 <a:solidFill>
-                  <a:srgbClr val="2E2A3A"/>
+                  <a:srgbClr val="FBFAF4"/>
                 </a:solidFill>
                 <a:latin typeface="Alexandria" pitchFamily="34" charset="0"/>
                 <a:ea typeface="Alexandria" pitchFamily="34" charset="-122"/>
@@ -2008,7 +2008,7 @@
             <a:lvl1pPr>
               <a:defRPr sz="2400">
                 <a:solidFill>
-                  <a:srgbClr val="5B5668"/>
+                  <a:srgbClr val="C9CDD8"/>
                 </a:solidFill>
                 <a:latin typeface="Alexandria"/>
                 <a:ea typeface="Alexandria"/>
@@ -2040,7 +2040,7 @@
     <p:bg>
       <p:bgPr>
         <a:solidFill>
-          <a:srgbClr val="FBFAF4"/>
+          <a:srgbClr val="172849"/>
         </a:solidFill>
       </p:bgPr>
     </p:bg>
@@ -2088,7 +2088,7 @@
             <a:lvl1pPr>
               <a:defRPr sz="2400">
                 <a:solidFill>
-                  <a:srgbClr val="5B5668"/>
+                  <a:srgbClr val="C9CDD8"/>
                 </a:solidFill>
                 <a:latin typeface="Alexandria"/>
                 <a:ea typeface="Alexandria"/>
@@ -2161,7 +2161,7 @@
             <a:lvl1pPr>
               <a:defRPr sz="2400">
                 <a:solidFill>
-                  <a:srgbClr val="5B5668"/>
+                  <a:srgbClr val="C9CDD8"/>
                 </a:solidFill>
                 <a:latin typeface="Alexandria"/>
                 <a:ea typeface="Alexandria"/>
@@ -2672,7 +2672,7 @@
             <a:r>
               <a:rPr lang="en-US" sz="2400" b="1" dirty="0">
                 <a:solidFill>
-                  <a:srgbClr val="962B7C"/>
+                  <a:srgbClr val="FFD23B"/>
                 </a:solidFill>
                 <a:latin typeface="Alexandria" pitchFamily="34" charset="0"/>
                 <a:ea typeface="Alexandria" pitchFamily="34" charset="-122"/>
@@ -2714,7 +2714,7 @@
             <a:r>
               <a:rPr lang="en-US" sz="4800" b="1" dirty="0">
                 <a:solidFill>
-                  <a:srgbClr val="2E2A3A"/>
+                  <a:srgbClr val="FBFAF4"/>
                 </a:solidFill>
                 <a:latin typeface="Alexandria" pitchFamily="34" charset="0"/>
                 <a:ea typeface="Alexandria" pitchFamily="34" charset="-122"/>
@@ -2756,7 +2756,7 @@
             <a:r>
               <a:rPr lang="en-US" sz="2800" dirty="0">
                 <a:solidFill>
-                  <a:srgbClr val="5B5668"/>
+                  <a:srgbClr val="C9CDD8"/>
                 </a:solidFill>
                 <a:latin typeface="Alexandria" pitchFamily="34" charset="0"/>
                 <a:ea typeface="Alexandria" pitchFamily="34" charset="-122"/>
@@ -2798,7 +2798,7 @@
             <a:r>
               <a:rPr lang="en-US" sz="2400" b="1" dirty="0">
                 <a:solidFill>
-                  <a:srgbClr val="2E2A3A"/>
+                  <a:srgbClr val="FBFAF4"/>
                 </a:solidFill>
                 <a:latin typeface="Alexandria" pitchFamily="34" charset="0"/>
                 <a:ea typeface="Alexandria" pitchFamily="34" charset="-122"/>
@@ -2930,7 +2930,7 @@
             <a:r>
               <a:rPr lang="en-US" sz="2400" b="1" dirty="0">
                 <a:solidFill>
-                  <a:srgbClr val="2E2A3A"/>
+                  <a:srgbClr val="172849"/>
                 </a:solidFill>
                 <a:latin typeface="Alexandria" pitchFamily="34" charset="0"/>
                 <a:ea typeface="Alexandria" pitchFamily="34" charset="-122"/>
@@ -2950,7 +2950,7 @@
             <a:r>
               <a:rPr lang="en-US" sz="3600" b="1" dirty="0">
                 <a:solidFill>
-                  <a:srgbClr val="2E2A3A"/>
+                  <a:srgbClr val="172849"/>
                 </a:solidFill>
                 <a:latin typeface="Alexandria" pitchFamily="34" charset="0"/>
                 <a:ea typeface="Alexandria" pitchFamily="34" charset="-122"/>
@@ -2992,7 +2992,7 @@
             <a:r>
               <a:rPr lang="en-US" sz="3000" b="1" dirty="0">
                 <a:solidFill>
-                  <a:srgbClr val="2E2A3A"/>
+                  <a:srgbClr val="FBFAF4"/>
                 </a:solidFill>
                 <a:latin typeface="Alexandria" pitchFamily="34" charset="0"/>
                 <a:ea typeface="Alexandria" pitchFamily="34" charset="-122"/>
@@ -3021,7 +3021,7 @@
             </a:avLst>
           </a:prstGeom>
           <a:solidFill>
-            <a:srgbClr val="D7ECE1"/>
+            <a:srgbClr val="214458"/>
           </a:solidFill>
           <a:ln/>
         </p:spPr>
@@ -3073,7 +3073,7 @@
             <a:r>
               <a:rPr lang="en-US" sz="2600" b="1" dirty="0">
                 <a:solidFill>
-                  <a:srgbClr val="2E2A3A"/>
+                  <a:srgbClr val="172849"/>
                 </a:solidFill>
                 <a:latin typeface="Alexandria" pitchFamily="34" charset="0"/>
                 <a:ea typeface="Alexandria" pitchFamily="34" charset="-122"/>
@@ -3115,7 +3115,7 @@
             <a:r>
               <a:rPr lang="en-US" sz="3000" dirty="0">
                 <a:solidFill>
-                  <a:srgbClr val="2E2A3A"/>
+                  <a:srgbClr val="FBFAF4"/>
                 </a:solidFill>
                 <a:latin typeface="Alexandria" pitchFamily="34" charset="0"/>
                 <a:ea typeface="Alexandria" pitchFamily="34" charset="-122"/>
@@ -3144,7 +3144,7 @@
             </a:avLst>
           </a:prstGeom>
           <a:solidFill>
-            <a:srgbClr val="FCD8DB"/>
+            <a:srgbClr val="453052"/>
           </a:solidFill>
           <a:ln/>
         </p:spPr>
@@ -3196,7 +3196,7 @@
             <a:r>
               <a:rPr lang="en-US" sz="2600" b="1" dirty="0">
                 <a:solidFill>
-                  <a:srgbClr val="2E2A3A"/>
+                  <a:srgbClr val="172849"/>
                 </a:solidFill>
                 <a:latin typeface="Alexandria" pitchFamily="34" charset="0"/>
                 <a:ea typeface="Alexandria" pitchFamily="34" charset="-122"/>
@@ -3238,7 +3238,7 @@
             <a:r>
               <a:rPr lang="en-US" sz="3000" dirty="0">
                 <a:solidFill>
-                  <a:srgbClr val="2E2A3A"/>
+                  <a:srgbClr val="FBFAF4"/>
                 </a:solidFill>
                 <a:latin typeface="Alexandria" pitchFamily="34" charset="0"/>
                 <a:ea typeface="Alexandria" pitchFamily="34" charset="-122"/>
@@ -3267,7 +3267,7 @@
             </a:avLst>
           </a:prstGeom>
           <a:solidFill>
-            <a:srgbClr val="CBE8F1"/>
+            <a:srgbClr val="144068"/>
           </a:solidFill>
           <a:ln/>
         </p:spPr>
@@ -3319,7 +3319,7 @@
             <a:r>
               <a:rPr lang="en-US" sz="2600" b="1" dirty="0">
                 <a:solidFill>
-                  <a:srgbClr val="2E2A3A"/>
+                  <a:srgbClr val="172849"/>
                 </a:solidFill>
                 <a:latin typeface="Alexandria" pitchFamily="34" charset="0"/>
                 <a:ea typeface="Alexandria" pitchFamily="34" charset="-122"/>
@@ -3361,7 +3361,7 @@
             <a:r>
               <a:rPr lang="en-US" sz="3000" dirty="0">
                 <a:solidFill>
-                  <a:srgbClr val="2E2A3A"/>
+                  <a:srgbClr val="FBFAF4"/>
                 </a:solidFill>
                 <a:latin typeface="Alexandria" pitchFamily="34" charset="0"/>
                 <a:ea typeface="Alexandria" pitchFamily="34" charset="-122"/>
@@ -3390,7 +3390,7 @@
             </a:avLst>
           </a:prstGeom>
           <a:solidFill>
-            <a:srgbClr val="FCE5D5"/>
+            <a:srgbClr val="453D4C"/>
           </a:solidFill>
           <a:ln/>
         </p:spPr>
@@ -3442,7 +3442,7 @@
             <a:r>
               <a:rPr lang="en-US" sz="2600" b="1" dirty="0">
                 <a:solidFill>
-                  <a:srgbClr val="2E2A3A"/>
+                  <a:srgbClr val="172849"/>
                 </a:solidFill>
                 <a:latin typeface="Alexandria" pitchFamily="34" charset="0"/>
                 <a:ea typeface="Alexandria" pitchFamily="34" charset="-122"/>
@@ -3484,7 +3484,7 @@
             <a:r>
               <a:rPr lang="en-US" sz="3000" dirty="0">
                 <a:solidFill>
-                  <a:srgbClr val="2E2A3A"/>
+                  <a:srgbClr val="FBFAF4"/>
                 </a:solidFill>
                 <a:latin typeface="Alexandria" pitchFamily="34" charset="0"/>
                 <a:ea typeface="Alexandria" pitchFamily="34" charset="-122"/>
@@ -3616,7 +3616,7 @@
             <a:r>
               <a:rPr lang="en-US" sz="2400" b="1" dirty="0">
                 <a:solidFill>
-                  <a:srgbClr val="2E2A3A"/>
+                  <a:srgbClr val="172849"/>
                 </a:solidFill>
                 <a:latin typeface="Alexandria" pitchFamily="34" charset="0"/>
                 <a:ea typeface="Alexandria" pitchFamily="34" charset="-122"/>
@@ -3636,7 +3636,7 @@
             <a:r>
               <a:rPr lang="en-US" sz="3600" b="1" dirty="0">
                 <a:solidFill>
-                  <a:srgbClr val="2E2A3A"/>
+                  <a:srgbClr val="172849"/>
                 </a:solidFill>
                 <a:latin typeface="Alexandria" pitchFamily="34" charset="0"/>
                 <a:ea typeface="Alexandria" pitchFamily="34" charset="-122"/>
@@ -3678,7 +3678,7 @@
             <a:r>
               <a:rPr lang="en-US" sz="3000" b="1" dirty="0">
                 <a:solidFill>
-                  <a:srgbClr val="2E2A3A"/>
+                  <a:srgbClr val="FBFAF4"/>
                 </a:solidFill>
                 <a:latin typeface="Alexandria" pitchFamily="34" charset="0"/>
                 <a:ea typeface="Alexandria" pitchFamily="34" charset="-122"/>
@@ -3707,7 +3707,7 @@
             </a:avLst>
           </a:prstGeom>
           <a:solidFill>
-            <a:srgbClr val="FCD8DB"/>
+            <a:srgbClr val="453052"/>
           </a:solidFill>
           <a:ln/>
         </p:spPr>
@@ -3759,7 +3759,7 @@
             <a:r>
               <a:rPr lang="en-US" sz="2600" b="1" dirty="0">
                 <a:solidFill>
-                  <a:srgbClr val="2E2A3A"/>
+                  <a:srgbClr val="172849"/>
                 </a:solidFill>
                 <a:latin typeface="Alexandria" pitchFamily="34" charset="0"/>
                 <a:ea typeface="Alexandria" pitchFamily="34" charset="-122"/>
@@ -3801,7 +3801,7 @@
             <a:r>
               <a:rPr lang="en-US" sz="3000" dirty="0">
                 <a:solidFill>
-                  <a:srgbClr val="2E2A3A"/>
+                  <a:srgbClr val="FBFAF4"/>
                 </a:solidFill>
                 <a:latin typeface="Alexandria" pitchFamily="34" charset="0"/>
                 <a:ea typeface="Alexandria" pitchFamily="34" charset="-122"/>
@@ -3830,7 +3830,7 @@
             </a:avLst>
           </a:prstGeom>
           <a:solidFill>
-            <a:srgbClr val="CBE8F1"/>
+            <a:srgbClr val="144068"/>
           </a:solidFill>
           <a:ln/>
         </p:spPr>
@@ -3882,7 +3882,7 @@
             <a:r>
               <a:rPr lang="en-US" sz="2600" b="1" dirty="0">
                 <a:solidFill>
-                  <a:srgbClr val="2E2A3A"/>
+                  <a:srgbClr val="172849"/>
                 </a:solidFill>
                 <a:latin typeface="Alexandria" pitchFamily="34" charset="0"/>
                 <a:ea typeface="Alexandria" pitchFamily="34" charset="-122"/>
@@ -3924,7 +3924,7 @@
             <a:r>
               <a:rPr lang="en-US" sz="3000" dirty="0">
                 <a:solidFill>
-                  <a:srgbClr val="2E2A3A"/>
+                  <a:srgbClr val="FBFAF4"/>
                 </a:solidFill>
                 <a:latin typeface="Alexandria" pitchFamily="34" charset="0"/>
                 <a:ea typeface="Alexandria" pitchFamily="34" charset="-122"/>
@@ -3953,7 +3953,7 @@
             </a:avLst>
           </a:prstGeom>
           <a:solidFill>
-            <a:srgbClr val="FCE5D5"/>
+            <a:srgbClr val="453D4C"/>
           </a:solidFill>
           <a:ln/>
         </p:spPr>
@@ -4005,7 +4005,7 @@
             <a:r>
               <a:rPr lang="en-US" sz="2600" b="1" dirty="0">
                 <a:solidFill>
-                  <a:srgbClr val="2E2A3A"/>
+                  <a:srgbClr val="172849"/>
                 </a:solidFill>
                 <a:latin typeface="Alexandria" pitchFamily="34" charset="0"/>
                 <a:ea typeface="Alexandria" pitchFamily="34" charset="-122"/>
@@ -4047,7 +4047,7 @@
             <a:r>
               <a:rPr lang="en-US" sz="3000" dirty="0">
                 <a:solidFill>
-                  <a:srgbClr val="2E2A3A"/>
+                  <a:srgbClr val="FBFAF4"/>
                 </a:solidFill>
                 <a:latin typeface="Alexandria" pitchFamily="34" charset="0"/>
                 <a:ea typeface="Alexandria" pitchFamily="34" charset="-122"/>
@@ -4076,7 +4076,7 @@
             </a:avLst>
           </a:prstGeom>
           <a:solidFill>
-            <a:srgbClr val="E7D1DC"/>
+            <a:srgbClr val="302953"/>
           </a:solidFill>
           <a:ln/>
         </p:spPr>
@@ -4170,7 +4170,7 @@
             <a:r>
               <a:rPr lang="en-US" sz="3000" dirty="0">
                 <a:solidFill>
-                  <a:srgbClr val="2E2A3A"/>
+                  <a:srgbClr val="FBFAF4"/>
                 </a:solidFill>
                 <a:latin typeface="Alexandria" pitchFamily="34" charset="0"/>
                 <a:ea typeface="Alexandria" pitchFamily="34" charset="-122"/>
@@ -4302,7 +4302,7 @@
             <a:r>
               <a:rPr lang="en-US" sz="2400" b="1" dirty="0">
                 <a:solidFill>
-                  <a:srgbClr val="2E2A3A"/>
+                  <a:srgbClr val="172849"/>
                 </a:solidFill>
                 <a:latin typeface="Alexandria" pitchFamily="34" charset="0"/>
                 <a:ea typeface="Alexandria" pitchFamily="34" charset="-122"/>
@@ -4322,7 +4322,7 @@
             <a:r>
               <a:rPr lang="en-US" sz="3600" b="1" dirty="0">
                 <a:solidFill>
-                  <a:srgbClr val="2E2A3A"/>
+                  <a:srgbClr val="172849"/>
                 </a:solidFill>
                 <a:latin typeface="Alexandria" pitchFamily="34" charset="0"/>
                 <a:ea typeface="Alexandria" pitchFamily="34" charset="-122"/>
@@ -4364,7 +4364,7 @@
             <a:r>
               <a:rPr lang="en-US" sz="2900" b="1" dirty="0">
                 <a:solidFill>
-                  <a:srgbClr val="2E2A3A"/>
+                  <a:srgbClr val="FBFAF4"/>
                 </a:solidFill>
                 <a:latin typeface="Alexandria" pitchFamily="34" charset="0"/>
                 <a:ea typeface="Alexandria" pitchFamily="34" charset="-122"/>
@@ -4393,7 +4393,7 @@
             </a:avLst>
           </a:prstGeom>
           <a:solidFill>
-            <a:srgbClr val="CBE8F1"/>
+            <a:srgbClr val="144068"/>
           </a:solidFill>
           <a:ln/>
         </p:spPr>
@@ -4445,7 +4445,7 @@
             <a:r>
               <a:rPr lang="en-US" sz="2600" b="1" dirty="0">
                 <a:solidFill>
-                  <a:srgbClr val="2E2A3A"/>
+                  <a:srgbClr val="172849"/>
                 </a:solidFill>
                 <a:latin typeface="Alexandria" pitchFamily="34" charset="0"/>
                 <a:ea typeface="Alexandria" pitchFamily="34" charset="-122"/>
@@ -4487,7 +4487,7 @@
             <a:r>
               <a:rPr lang="en-US" sz="2900" dirty="0">
                 <a:solidFill>
-                  <a:srgbClr val="2E2A3A"/>
+                  <a:srgbClr val="FBFAF4"/>
                 </a:solidFill>
                 <a:latin typeface="Alexandria" pitchFamily="34" charset="0"/>
                 <a:ea typeface="Alexandria" pitchFamily="34" charset="-122"/>
@@ -4516,7 +4516,7 @@
             </a:avLst>
           </a:prstGeom>
           <a:solidFill>
-            <a:srgbClr val="FCE5D5"/>
+            <a:srgbClr val="453D4C"/>
           </a:solidFill>
           <a:ln/>
         </p:spPr>
@@ -4568,7 +4568,7 @@
             <a:r>
               <a:rPr lang="en-US" sz="2600" b="1" dirty="0">
                 <a:solidFill>
-                  <a:srgbClr val="2E2A3A"/>
+                  <a:srgbClr val="172849"/>
                 </a:solidFill>
                 <a:latin typeface="Alexandria" pitchFamily="34" charset="0"/>
                 <a:ea typeface="Alexandria" pitchFamily="34" charset="-122"/>
@@ -4610,7 +4610,7 @@
             <a:r>
               <a:rPr lang="en-US" sz="2900" dirty="0">
                 <a:solidFill>
-                  <a:srgbClr val="2E2A3A"/>
+                  <a:srgbClr val="FBFAF4"/>
                 </a:solidFill>
                 <a:latin typeface="Alexandria" pitchFamily="34" charset="0"/>
                 <a:ea typeface="Alexandria" pitchFamily="34" charset="-122"/>
@@ -4639,7 +4639,7 @@
             </a:avLst>
           </a:prstGeom>
           <a:solidFill>
-            <a:srgbClr val="E7D1DC"/>
+            <a:srgbClr val="302953"/>
           </a:solidFill>
           <a:ln/>
         </p:spPr>
@@ -4733,7 +4733,7 @@
             <a:r>
               <a:rPr lang="en-US" sz="2900" dirty="0">
                 <a:solidFill>
-                  <a:srgbClr val="2E2A3A"/>
+                  <a:srgbClr val="FBFAF4"/>
                 </a:solidFill>
                 <a:latin typeface="Alexandria" pitchFamily="34" charset="0"/>
                 <a:ea typeface="Alexandria" pitchFamily="34" charset="-122"/>
@@ -4762,7 +4762,7 @@
             </a:avLst>
           </a:prstGeom>
           <a:solidFill>
-            <a:srgbClr val="FCF2CF"/>
+            <a:srgbClr val="454A46"/>
           </a:solidFill>
           <a:ln/>
         </p:spPr>
@@ -4814,7 +4814,7 @@
             <a:r>
               <a:rPr lang="en-US" sz="2600" b="1" dirty="0">
                 <a:solidFill>
-                  <a:srgbClr val="2E2A3A"/>
+                  <a:srgbClr val="172849"/>
                 </a:solidFill>
                 <a:latin typeface="Alexandria" pitchFamily="34" charset="0"/>
                 <a:ea typeface="Alexandria" pitchFamily="34" charset="-122"/>
@@ -4856,7 +4856,7 @@
             <a:r>
               <a:rPr lang="en-US" sz="2900" dirty="0">
                 <a:solidFill>
-                  <a:srgbClr val="2E2A3A"/>
+                  <a:srgbClr val="FBFAF4"/>
                 </a:solidFill>
                 <a:latin typeface="Alexandria" pitchFamily="34" charset="0"/>
                 <a:ea typeface="Alexandria" pitchFamily="34" charset="-122"/>
@@ -4988,7 +4988,7 @@
             <a:r>
               <a:rPr lang="en-US" sz="2400" b="1" dirty="0">
                 <a:solidFill>
-                  <a:srgbClr val="2E2A3A"/>
+                  <a:srgbClr val="172849"/>
                 </a:solidFill>
                 <a:latin typeface="Alexandria" pitchFamily="34" charset="0"/>
                 <a:ea typeface="Alexandria" pitchFamily="34" charset="-122"/>
@@ -5008,7 +5008,7 @@
             <a:r>
               <a:rPr lang="en-US" sz="3600" b="1" dirty="0">
                 <a:solidFill>
-                  <a:srgbClr val="2E2A3A"/>
+                  <a:srgbClr val="172849"/>
                 </a:solidFill>
                 <a:latin typeface="Alexandria" pitchFamily="34" charset="0"/>
                 <a:ea typeface="Alexandria" pitchFamily="34" charset="-122"/>
@@ -5050,7 +5050,7 @@
             <a:r>
               <a:rPr lang="en-US" sz="3000" b="1" dirty="0">
                 <a:solidFill>
-                  <a:srgbClr val="2E2A3A"/>
+                  <a:srgbClr val="FBFAF4"/>
                 </a:solidFill>
                 <a:latin typeface="Alexandria" pitchFamily="34" charset="0"/>
                 <a:ea typeface="Alexandria" pitchFamily="34" charset="-122"/>
@@ -5079,7 +5079,7 @@
             </a:avLst>
           </a:prstGeom>
           <a:solidFill>
-            <a:srgbClr val="FCE5D5"/>
+            <a:srgbClr val="453D4C"/>
           </a:solidFill>
           <a:ln/>
         </p:spPr>
@@ -5131,7 +5131,7 @@
             <a:r>
               <a:rPr lang="en-US" sz="2600" b="1" dirty="0">
                 <a:solidFill>
-                  <a:srgbClr val="2E2A3A"/>
+                  <a:srgbClr val="172849"/>
                 </a:solidFill>
                 <a:latin typeface="Alexandria" pitchFamily="34" charset="0"/>
                 <a:ea typeface="Alexandria" pitchFamily="34" charset="-122"/>
@@ -5173,7 +5173,7 @@
             <a:r>
               <a:rPr lang="en-US" sz="3000" dirty="0">
                 <a:solidFill>
-                  <a:srgbClr val="2E2A3A"/>
+                  <a:srgbClr val="FBFAF4"/>
                 </a:solidFill>
                 <a:latin typeface="Alexandria" pitchFamily="34" charset="0"/>
                 <a:ea typeface="Alexandria" pitchFamily="34" charset="-122"/>
@@ -5202,7 +5202,7 @@
             </a:avLst>
           </a:prstGeom>
           <a:solidFill>
-            <a:srgbClr val="E7D1DC"/>
+            <a:srgbClr val="302953"/>
           </a:solidFill>
           <a:ln/>
         </p:spPr>
@@ -5296,7 +5296,7 @@
             <a:r>
               <a:rPr lang="en-US" sz="3000" dirty="0">
                 <a:solidFill>
-                  <a:srgbClr val="2E2A3A"/>
+                  <a:srgbClr val="FBFAF4"/>
                 </a:solidFill>
                 <a:latin typeface="Alexandria" pitchFamily="34" charset="0"/>
                 <a:ea typeface="Alexandria" pitchFamily="34" charset="-122"/>
@@ -5325,7 +5325,7 @@
             </a:avLst>
           </a:prstGeom>
           <a:solidFill>
-            <a:srgbClr val="FCF2CF"/>
+            <a:srgbClr val="454A46"/>
           </a:solidFill>
           <a:ln/>
         </p:spPr>
@@ -5377,7 +5377,7 @@
             <a:r>
               <a:rPr lang="en-US" sz="2600" b="1" dirty="0">
                 <a:solidFill>
-                  <a:srgbClr val="2E2A3A"/>
+                  <a:srgbClr val="172849"/>
                 </a:solidFill>
                 <a:latin typeface="Alexandria" pitchFamily="34" charset="0"/>
                 <a:ea typeface="Alexandria" pitchFamily="34" charset="-122"/>
@@ -5419,7 +5419,7 @@
             <a:r>
               <a:rPr lang="en-US" sz="3000" dirty="0">
                 <a:solidFill>
-                  <a:srgbClr val="2E2A3A"/>
+                  <a:srgbClr val="FBFAF4"/>
                 </a:solidFill>
                 <a:latin typeface="Alexandria" pitchFamily="34" charset="0"/>
                 <a:ea typeface="Alexandria" pitchFamily="34" charset="-122"/>
@@ -5448,7 +5448,7 @@
             </a:avLst>
           </a:prstGeom>
           <a:solidFill>
-            <a:srgbClr val="D7ECE1"/>
+            <a:srgbClr val="214458"/>
           </a:solidFill>
           <a:ln/>
         </p:spPr>
@@ -5500,7 +5500,7 @@
             <a:r>
               <a:rPr lang="en-US" sz="2600" b="1" dirty="0">
                 <a:solidFill>
-                  <a:srgbClr val="2E2A3A"/>
+                  <a:srgbClr val="172849"/>
                 </a:solidFill>
                 <a:latin typeface="Alexandria" pitchFamily="34" charset="0"/>
                 <a:ea typeface="Alexandria" pitchFamily="34" charset="-122"/>
@@ -5542,7 +5542,7 @@
             <a:r>
               <a:rPr lang="en-US" sz="3000" dirty="0">
                 <a:solidFill>
-                  <a:srgbClr val="2E2A3A"/>
+                  <a:srgbClr val="FBFAF4"/>
                 </a:solidFill>
                 <a:latin typeface="Alexandria" pitchFamily="34" charset="0"/>
                 <a:ea typeface="Alexandria" pitchFamily="34" charset="-122"/>
@@ -5709,7 +5709,7 @@
             <a:r>
               <a:rPr lang="en-US" sz="9600" b="1" dirty="0">
                 <a:solidFill>
-                  <a:srgbClr val="2E2A3A"/>
+                  <a:srgbClr val="172849"/>
                 </a:solidFill>
                 <a:latin typeface="Alexandria" pitchFamily="34" charset="0"/>
                 <a:ea typeface="Alexandria" pitchFamily="34" charset="-122"/>
@@ -5751,7 +5751,7 @@
             <a:r>
               <a:rPr lang="en-US" sz="3900" b="1" dirty="0">
                 <a:solidFill>
-                  <a:srgbClr val="2E2A3A"/>
+                  <a:srgbClr val="FBFAF4"/>
                 </a:solidFill>
                 <a:latin typeface="Alexandria" pitchFamily="34" charset="0"/>
                 <a:ea typeface="Alexandria" pitchFamily="34" charset="-122"/>
@@ -5793,7 +5793,7 @@
             <a:r>
               <a:rPr lang="en-US" sz="3000" dirty="0">
                 <a:solidFill>
-                  <a:srgbClr val="5B5668"/>
+                  <a:srgbClr val="C9CDD8"/>
                 </a:solidFill>
                 <a:latin typeface="Alexandria" pitchFamily="34" charset="0"/>
                 <a:ea typeface="Alexandria" pitchFamily="34" charset="-122"/>
@@ -5835,7 +5835,7 @@
             <a:lvl1pPr>
               <a:defRPr sz="2400">
                 <a:solidFill>
-                  <a:srgbClr val="5B5668"/>
+                  <a:srgbClr val="C9CDD8"/>
                 </a:solidFill>
                 <a:latin typeface="Alexandria"/>
                 <a:ea typeface="Alexandria"/>
@@ -5970,7 +5970,7 @@
             <a:r>
               <a:rPr lang="en-US" sz="3600" b="1" dirty="0">
                 <a:solidFill>
-                  <a:srgbClr val="2E2A3A"/>
+                  <a:srgbClr val="FBFAF4"/>
                 </a:solidFill>
                 <a:latin typeface="Alexandria" pitchFamily="34" charset="0"/>
                 <a:ea typeface="Alexandria" pitchFamily="34" charset="-122"/>
@@ -5999,7 +5999,7 @@
             </a:avLst>
           </a:prstGeom>
           <a:solidFill>
-            <a:srgbClr val="FCDBC5"/>
+            <a:srgbClr val="5D484E"/>
           </a:solidFill>
           <a:ln/>
         </p:spPr>
@@ -6051,7 +6051,7 @@
             <a:r>
               <a:rPr lang="en-US" sz="2600" b="1" dirty="0">
                 <a:solidFill>
-                  <a:srgbClr val="2E2A3A"/>
+                  <a:srgbClr val="172849"/>
                 </a:solidFill>
                 <a:latin typeface="Alexandria" pitchFamily="34" charset="0"/>
                 <a:ea typeface="Alexandria" pitchFamily="34" charset="-122"/>
@@ -6093,7 +6093,7 @@
             <a:r>
               <a:rPr lang="en-US" sz="2600" b="1" dirty="0">
                 <a:solidFill>
-                  <a:srgbClr val="2E2A3A"/>
+                  <a:srgbClr val="FBFAF4"/>
                 </a:solidFill>
                 <a:latin typeface="Alexandria" pitchFamily="34" charset="0"/>
                 <a:ea typeface="Alexandria" pitchFamily="34" charset="-122"/>
@@ -6122,7 +6122,7 @@
             </a:avLst>
           </a:prstGeom>
           <a:solidFill>
-            <a:srgbClr val="D7EDF2"/>
+            <a:srgbClr val="153A60"/>
           </a:solidFill>
           <a:ln/>
         </p:spPr>
@@ -6174,7 +6174,7 @@
             <a:r>
               <a:rPr lang="en-US" sz="4800" b="1" dirty="0">
                 <a:solidFill>
-                  <a:srgbClr val="2E2A3A"/>
+                  <a:srgbClr val="172849"/>
                 </a:solidFill>
                 <a:latin typeface="Alexandria" pitchFamily="34" charset="0"/>
                 <a:ea typeface="Alexandria" pitchFamily="34" charset="-122"/>
@@ -6216,7 +6216,7 @@
             <a:r>
               <a:rPr lang="en-US" sz="2600" dirty="0">
                 <a:solidFill>
-                  <a:srgbClr val="2E2A3A"/>
+                  <a:srgbClr val="FBFAF4"/>
                 </a:solidFill>
                 <a:latin typeface="Alexandria" pitchFamily="34" charset="0"/>
                 <a:ea typeface="Alexandria" pitchFamily="34" charset="-122"/>
@@ -6245,7 +6245,7 @@
             </a:avLst>
           </a:prstGeom>
           <a:solidFill>
-            <a:srgbClr val="FCEADD"/>
+            <a:srgbClr val="3A384B"/>
           </a:solidFill>
           <a:ln/>
         </p:spPr>
@@ -6297,7 +6297,7 @@
             <a:r>
               <a:rPr lang="en-US" sz="4800" b="1" dirty="0">
                 <a:solidFill>
-                  <a:srgbClr val="2E2A3A"/>
+                  <a:srgbClr val="172849"/>
                 </a:solidFill>
                 <a:latin typeface="Alexandria" pitchFamily="34" charset="0"/>
                 <a:ea typeface="Alexandria" pitchFamily="34" charset="-122"/>
@@ -6339,7 +6339,7 @@
             <a:r>
               <a:rPr lang="en-US" sz="2600" dirty="0">
                 <a:solidFill>
-                  <a:srgbClr val="2E2A3A"/>
+                  <a:srgbClr val="FBFAF4"/>
                 </a:solidFill>
                 <a:latin typeface="Alexandria" pitchFamily="34" charset="0"/>
                 <a:ea typeface="Alexandria" pitchFamily="34" charset="-122"/>
@@ -6368,7 +6368,7 @@
             </a:avLst>
           </a:prstGeom>
           <a:solidFill>
-            <a:srgbClr val="ECDBE2"/>
+            <a:srgbClr val="2A2851"/>
           </a:solidFill>
           <a:ln/>
         </p:spPr>
@@ -6462,7 +6462,7 @@
             <a:r>
               <a:rPr lang="en-US" sz="2600" dirty="0">
                 <a:solidFill>
-                  <a:srgbClr val="2E2A3A"/>
+                  <a:srgbClr val="FBFAF4"/>
                 </a:solidFill>
                 <a:latin typeface="Alexandria" pitchFamily="34" charset="0"/>
                 <a:ea typeface="Alexandria" pitchFamily="34" charset="-122"/>
@@ -6504,7 +6504,7 @@
             <a:lvl1pPr>
               <a:defRPr sz="2400">
                 <a:solidFill>
-                  <a:srgbClr val="5B5668"/>
+                  <a:srgbClr val="C9CDD8"/>
                 </a:solidFill>
                 <a:latin typeface="Alexandria"/>
                 <a:ea typeface="Alexandria"/>
@@ -6639,7 +6639,7 @@
             <a:r>
               <a:rPr lang="en-US" sz="3600" b="1" dirty="0">
                 <a:solidFill>
-                  <a:srgbClr val="2E2A3A"/>
+                  <a:srgbClr val="FBFAF4"/>
                 </a:solidFill>
                 <a:latin typeface="Alexandria" pitchFamily="34" charset="0"/>
                 <a:ea typeface="Alexandria" pitchFamily="34" charset="-122"/>
@@ -6698,7 +6698,7 @@
             <a:r>
               <a:rPr lang="en-US" sz="2400" b="1" dirty="0">
                 <a:solidFill>
-                  <a:srgbClr val="2E2A3A"/>
+                  <a:srgbClr val="172849"/>
                 </a:solidFill>
                 <a:latin typeface="Alexandria" pitchFamily="34" charset="0"/>
                 <a:ea typeface="Alexandria" pitchFamily="34" charset="-122"/>
@@ -6740,7 +6740,7 @@
             <a:r>
               <a:rPr lang="en-US" sz="2700" dirty="0">
                 <a:solidFill>
-                  <a:srgbClr val="2E2A3A"/>
+                  <a:srgbClr val="FBFAF4"/>
                 </a:solidFill>
                 <a:latin typeface="Alexandria" pitchFamily="34" charset="0"/>
                 <a:ea typeface="Alexandria" pitchFamily="34" charset="-122"/>
@@ -6757,7 +6757,7 @@
             <a:r>
               <a:rPr lang="en-US" sz="2700" b="1" dirty="0">
                 <a:solidFill>
-                  <a:srgbClr val="2E2A3A"/>
+                  <a:srgbClr val="FBFAF4"/>
                 </a:solidFill>
                 <a:latin typeface="Alexandria" pitchFamily="34" charset="0"/>
                 <a:ea typeface="Alexandria" pitchFamily="34" charset="-122"/>
@@ -6774,7 +6774,7 @@
             <a:r>
               <a:rPr lang="en-US" sz="2700" dirty="0">
                 <a:solidFill>
-                  <a:srgbClr val="2E2A3A"/>
+                  <a:srgbClr val="FBFAF4"/>
                 </a:solidFill>
                 <a:latin typeface="Alexandria" pitchFamily="34" charset="0"/>
                 <a:ea typeface="Alexandria" pitchFamily="34" charset="-122"/>
@@ -6875,7 +6875,7 @@
             <a:r>
               <a:rPr lang="en-US" sz="2700" dirty="0">
                 <a:solidFill>
-                  <a:srgbClr val="2E2A3A"/>
+                  <a:srgbClr val="FBFAF4"/>
                 </a:solidFill>
                 <a:latin typeface="Alexandria" pitchFamily="34" charset="0"/>
                 <a:ea typeface="Alexandria" pitchFamily="34" charset="-122"/>
@@ -6934,7 +6934,7 @@
             <a:r>
               <a:rPr lang="en-US" sz="2400" b="1" dirty="0">
                 <a:solidFill>
-                  <a:srgbClr val="2E2A3A"/>
+                  <a:srgbClr val="172849"/>
                 </a:solidFill>
                 <a:latin typeface="Alexandria" pitchFamily="34" charset="0"/>
                 <a:ea typeface="Alexandria" pitchFamily="34" charset="-122"/>
@@ -6976,7 +6976,7 @@
             <a:r>
               <a:rPr lang="en-US" sz="2700" dirty="0">
                 <a:solidFill>
-                  <a:srgbClr val="2E2A3A"/>
+                  <a:srgbClr val="FBFAF4"/>
                 </a:solidFill>
                 <a:latin typeface="Alexandria" pitchFamily="34" charset="0"/>
                 <a:ea typeface="Alexandria" pitchFamily="34" charset="-122"/>
@@ -7035,7 +7035,7 @@
             <a:r>
               <a:rPr lang="en-US" sz="2400" b="1" dirty="0">
                 <a:solidFill>
-                  <a:srgbClr val="2E2A3A"/>
+                  <a:srgbClr val="172849"/>
                 </a:solidFill>
                 <a:latin typeface="Alexandria" pitchFamily="34" charset="0"/>
                 <a:ea typeface="Alexandria" pitchFamily="34" charset="-122"/>
@@ -7077,7 +7077,7 @@
             <a:r>
               <a:rPr lang="en-US" sz="2700" dirty="0">
                 <a:solidFill>
-                  <a:srgbClr val="2E2A3A"/>
+                  <a:srgbClr val="FBFAF4"/>
                 </a:solidFill>
                 <a:latin typeface="Alexandria" pitchFamily="34" charset="0"/>
                 <a:ea typeface="Alexandria" pitchFamily="34" charset="-122"/>
@@ -7106,7 +7106,7 @@
             </a:avLst>
           </a:prstGeom>
           <a:solidFill>
-            <a:srgbClr val="DDBCD0"/>
+            <a:srgbClr val="3D2958"/>
           </a:solidFill>
           <a:ln/>
         </p:spPr>
@@ -7200,7 +7200,7 @@
             <a:r>
               <a:rPr lang="en-US" sz="2600" b="1" dirty="0">
                 <a:solidFill>
-                  <a:srgbClr val="2E2A3A"/>
+                  <a:srgbClr val="FBFAF4"/>
                 </a:solidFill>
                 <a:latin typeface="Alexandria" pitchFamily="34" charset="0"/>
                 <a:ea typeface="Alexandria" pitchFamily="34" charset="-122"/>
@@ -7242,7 +7242,7 @@
             <a:lvl1pPr>
               <a:defRPr sz="2400">
                 <a:solidFill>
-                  <a:srgbClr val="5B5668"/>
+                  <a:srgbClr val="C9CDD8"/>
                 </a:solidFill>
                 <a:latin typeface="Alexandria"/>
                 <a:ea typeface="Alexandria"/>
@@ -7380,7 +7380,7 @@
             <a:r>
               <a:rPr lang="en-US" sz="2400" b="1" dirty="0">
                 <a:solidFill>
-                  <a:srgbClr val="2E2A3A"/>
+                  <a:srgbClr val="172849"/>
                 </a:solidFill>
                 <a:latin typeface="Alexandria" pitchFamily="34" charset="0"/>
                 <a:ea typeface="Alexandria" pitchFamily="34" charset="-122"/>
@@ -7400,7 +7400,7 @@
             <a:r>
               <a:rPr lang="en-US" sz="3600" b="1" dirty="0">
                 <a:solidFill>
-                  <a:srgbClr val="2E2A3A"/>
+                  <a:srgbClr val="172849"/>
                 </a:solidFill>
                 <a:latin typeface="Alexandria" pitchFamily="34" charset="0"/>
                 <a:ea typeface="Alexandria" pitchFamily="34" charset="-122"/>
@@ -7442,7 +7442,7 @@
             <a:r>
               <a:rPr lang="en-US" sz="3000" b="1" dirty="0">
                 <a:solidFill>
-                  <a:srgbClr val="2E2A3A"/>
+                  <a:srgbClr val="FBFAF4"/>
                 </a:solidFill>
                 <a:latin typeface="Alexandria" pitchFamily="34" charset="0"/>
                 <a:ea typeface="Alexandria" pitchFamily="34" charset="-122"/>
@@ -7471,7 +7471,7 @@
             </a:avLst>
           </a:prstGeom>
           <a:solidFill>
-            <a:srgbClr val="D7ECE1"/>
+            <a:srgbClr val="214458"/>
           </a:solidFill>
           <a:ln/>
         </p:spPr>
@@ -7523,7 +7523,7 @@
             <a:r>
               <a:rPr lang="en-US" sz="2600" b="1" dirty="0">
                 <a:solidFill>
-                  <a:srgbClr val="2E2A3A"/>
+                  <a:srgbClr val="172849"/>
                 </a:solidFill>
                 <a:latin typeface="Alexandria" pitchFamily="34" charset="0"/>
                 <a:ea typeface="Alexandria" pitchFamily="34" charset="-122"/>
@@ -7565,7 +7565,7 @@
             <a:r>
               <a:rPr lang="en-US" sz="3000" dirty="0">
                 <a:solidFill>
-                  <a:srgbClr val="2E2A3A"/>
+                  <a:srgbClr val="FBFAF4"/>
                 </a:solidFill>
                 <a:latin typeface="Alexandria" pitchFamily="34" charset="0"/>
                 <a:ea typeface="Alexandria" pitchFamily="34" charset="-122"/>
@@ -7594,7 +7594,7 @@
             </a:avLst>
           </a:prstGeom>
           <a:solidFill>
-            <a:srgbClr val="FCD8DB"/>
+            <a:srgbClr val="453052"/>
           </a:solidFill>
           <a:ln/>
         </p:spPr>
@@ -7646,7 +7646,7 @@
             <a:r>
               <a:rPr lang="en-US" sz="2600" b="1" dirty="0">
                 <a:solidFill>
-                  <a:srgbClr val="2E2A3A"/>
+                  <a:srgbClr val="172849"/>
                 </a:solidFill>
                 <a:latin typeface="Alexandria" pitchFamily="34" charset="0"/>
                 <a:ea typeface="Alexandria" pitchFamily="34" charset="-122"/>
@@ -7688,7 +7688,7 @@
             <a:r>
               <a:rPr lang="en-US" sz="3000" dirty="0">
                 <a:solidFill>
-                  <a:srgbClr val="2E2A3A"/>
+                  <a:srgbClr val="FBFAF4"/>
                 </a:solidFill>
                 <a:latin typeface="Alexandria" pitchFamily="34" charset="0"/>
                 <a:ea typeface="Alexandria" pitchFamily="34" charset="-122"/>
@@ -7717,7 +7717,7 @@
             </a:avLst>
           </a:prstGeom>
           <a:solidFill>
-            <a:srgbClr val="CBE8F1"/>
+            <a:srgbClr val="144068"/>
           </a:solidFill>
           <a:ln/>
         </p:spPr>
@@ -7769,7 +7769,7 @@
             <a:r>
               <a:rPr lang="en-US" sz="2600" b="1" dirty="0">
                 <a:solidFill>
-                  <a:srgbClr val="2E2A3A"/>
+                  <a:srgbClr val="172849"/>
                 </a:solidFill>
                 <a:latin typeface="Alexandria" pitchFamily="34" charset="0"/>
                 <a:ea typeface="Alexandria" pitchFamily="34" charset="-122"/>
@@ -7811,7 +7811,7 @@
             <a:r>
               <a:rPr lang="en-US" sz="3000" dirty="0">
                 <a:solidFill>
-                  <a:srgbClr val="2E2A3A"/>
+                  <a:srgbClr val="FBFAF4"/>
                 </a:solidFill>
                 <a:latin typeface="Alexandria" pitchFamily="34" charset="0"/>
                 <a:ea typeface="Alexandria" pitchFamily="34" charset="-122"/>
@@ -7840,7 +7840,7 @@
             </a:avLst>
           </a:prstGeom>
           <a:solidFill>
-            <a:srgbClr val="FCE5D5"/>
+            <a:srgbClr val="453D4C"/>
           </a:solidFill>
           <a:ln/>
         </p:spPr>
@@ -7892,7 +7892,7 @@
             <a:r>
               <a:rPr lang="en-US" sz="2600" b="1" dirty="0">
                 <a:solidFill>
-                  <a:srgbClr val="2E2A3A"/>
+                  <a:srgbClr val="172849"/>
                 </a:solidFill>
                 <a:latin typeface="Alexandria" pitchFamily="34" charset="0"/>
                 <a:ea typeface="Alexandria" pitchFamily="34" charset="-122"/>
@@ -7934,7 +7934,7 @@
             <a:r>
               <a:rPr lang="en-US" sz="3000" dirty="0">
                 <a:solidFill>
-                  <a:srgbClr val="2E2A3A"/>
+                  <a:srgbClr val="FBFAF4"/>
                 </a:solidFill>
                 <a:latin typeface="Alexandria" pitchFamily="34" charset="0"/>
                 <a:ea typeface="Alexandria" pitchFamily="34" charset="-122"/>
@@ -8066,7 +8066,7 @@
             <a:r>
               <a:rPr lang="en-US" sz="2400" b="1" dirty="0">
                 <a:solidFill>
-                  <a:srgbClr val="2E2A3A"/>
+                  <a:srgbClr val="172849"/>
                 </a:solidFill>
                 <a:latin typeface="Alexandria" pitchFamily="34" charset="0"/>
                 <a:ea typeface="Alexandria" pitchFamily="34" charset="-122"/>
@@ -8086,7 +8086,7 @@
             <a:r>
               <a:rPr lang="en-US" sz="3600" b="1" dirty="0">
                 <a:solidFill>
-                  <a:srgbClr val="2E2A3A"/>
+                  <a:srgbClr val="172849"/>
                 </a:solidFill>
                 <a:latin typeface="Alexandria" pitchFamily="34" charset="0"/>
                 <a:ea typeface="Alexandria" pitchFamily="34" charset="-122"/>
@@ -8128,7 +8128,7 @@
             <a:r>
               <a:rPr lang="en-US" sz="3000" b="1" dirty="0">
                 <a:solidFill>
-                  <a:srgbClr val="2E2A3A"/>
+                  <a:srgbClr val="FBFAF4"/>
                 </a:solidFill>
                 <a:latin typeface="Alexandria" pitchFamily="34" charset="0"/>
                 <a:ea typeface="Alexandria" pitchFamily="34" charset="-122"/>
@@ -8157,7 +8157,7 @@
             </a:avLst>
           </a:prstGeom>
           <a:solidFill>
-            <a:srgbClr val="FCD8DB"/>
+            <a:srgbClr val="453052"/>
           </a:solidFill>
           <a:ln/>
         </p:spPr>
@@ -8209,7 +8209,7 @@
             <a:r>
               <a:rPr lang="en-US" sz="2600" b="1" dirty="0">
                 <a:solidFill>
-                  <a:srgbClr val="2E2A3A"/>
+                  <a:srgbClr val="172849"/>
                 </a:solidFill>
                 <a:latin typeface="Alexandria" pitchFamily="34" charset="0"/>
                 <a:ea typeface="Alexandria" pitchFamily="34" charset="-122"/>
@@ -8251,7 +8251,7 @@
             <a:r>
               <a:rPr lang="en-US" sz="3000" dirty="0">
                 <a:solidFill>
-                  <a:srgbClr val="2E2A3A"/>
+                  <a:srgbClr val="FBFAF4"/>
                 </a:solidFill>
                 <a:latin typeface="Alexandria" pitchFamily="34" charset="0"/>
                 <a:ea typeface="Alexandria" pitchFamily="34" charset="-122"/>
@@ -8280,7 +8280,7 @@
             </a:avLst>
           </a:prstGeom>
           <a:solidFill>
-            <a:srgbClr val="CBE8F1"/>
+            <a:srgbClr val="144068"/>
           </a:solidFill>
           <a:ln/>
         </p:spPr>
@@ -8332,7 +8332,7 @@
             <a:r>
               <a:rPr lang="en-US" sz="2600" b="1" dirty="0">
                 <a:solidFill>
-                  <a:srgbClr val="2E2A3A"/>
+                  <a:srgbClr val="172849"/>
                 </a:solidFill>
                 <a:latin typeface="Alexandria" pitchFamily="34" charset="0"/>
                 <a:ea typeface="Alexandria" pitchFamily="34" charset="-122"/>
@@ -8374,7 +8374,7 @@
             <a:r>
               <a:rPr lang="en-US" sz="3000" dirty="0">
                 <a:solidFill>
-                  <a:srgbClr val="2E2A3A"/>
+                  <a:srgbClr val="FBFAF4"/>
                 </a:solidFill>
                 <a:latin typeface="Alexandria" pitchFamily="34" charset="0"/>
                 <a:ea typeface="Alexandria" pitchFamily="34" charset="-122"/>
@@ -8403,7 +8403,7 @@
             </a:avLst>
           </a:prstGeom>
           <a:solidFill>
-            <a:srgbClr val="FCE5D5"/>
+            <a:srgbClr val="453D4C"/>
           </a:solidFill>
           <a:ln/>
         </p:spPr>
@@ -8455,7 +8455,7 @@
             <a:r>
               <a:rPr lang="en-US" sz="2600" b="1" dirty="0">
                 <a:solidFill>
-                  <a:srgbClr val="2E2A3A"/>
+                  <a:srgbClr val="172849"/>
                 </a:solidFill>
                 <a:latin typeface="Alexandria" pitchFamily="34" charset="0"/>
                 <a:ea typeface="Alexandria" pitchFamily="34" charset="-122"/>
@@ -8497,7 +8497,7 @@
             <a:r>
               <a:rPr lang="en-US" sz="3000" dirty="0">
                 <a:solidFill>
-                  <a:srgbClr val="2E2A3A"/>
+                  <a:srgbClr val="FBFAF4"/>
                 </a:solidFill>
                 <a:latin typeface="Alexandria" pitchFamily="34" charset="0"/>
                 <a:ea typeface="Alexandria" pitchFamily="34" charset="-122"/>
@@ -8526,7 +8526,7 @@
             </a:avLst>
           </a:prstGeom>
           <a:solidFill>
-            <a:srgbClr val="E7D1DC"/>
+            <a:srgbClr val="302953"/>
           </a:solidFill>
           <a:ln/>
         </p:spPr>
@@ -8620,7 +8620,7 @@
             <a:r>
               <a:rPr lang="en-US" sz="3000" dirty="0">
                 <a:solidFill>
-                  <a:srgbClr val="2E2A3A"/>
+                  <a:srgbClr val="FBFAF4"/>
                 </a:solidFill>
                 <a:latin typeface="Alexandria" pitchFamily="34" charset="0"/>
                 <a:ea typeface="Alexandria" pitchFamily="34" charset="-122"/>
@@ -8752,7 +8752,7 @@
             <a:r>
               <a:rPr lang="en-US" sz="2400" b="1" dirty="0">
                 <a:solidFill>
-                  <a:srgbClr val="2E2A3A"/>
+                  <a:srgbClr val="172849"/>
                 </a:solidFill>
                 <a:latin typeface="Alexandria" pitchFamily="34" charset="0"/>
                 <a:ea typeface="Alexandria" pitchFamily="34" charset="-122"/>
@@ -8772,7 +8772,7 @@
             <a:r>
               <a:rPr lang="en-US" sz="3600" b="1" dirty="0">
                 <a:solidFill>
-                  <a:srgbClr val="2E2A3A"/>
+                  <a:srgbClr val="172849"/>
                 </a:solidFill>
                 <a:latin typeface="Alexandria" pitchFamily="34" charset="0"/>
                 <a:ea typeface="Alexandria" pitchFamily="34" charset="-122"/>
@@ -8814,7 +8814,7 @@
             <a:r>
               <a:rPr lang="en-US" sz="2400" b="1" dirty="0">
                 <a:solidFill>
-                  <a:srgbClr val="2E2A3A"/>
+                  <a:srgbClr val="FBFAF4"/>
                 </a:solidFill>
                 <a:latin typeface="Alexandria" pitchFamily="34" charset="0"/>
                 <a:ea typeface="Alexandria" pitchFamily="34" charset="-122"/>
@@ -8843,7 +8843,7 @@
             </a:avLst>
           </a:prstGeom>
           <a:solidFill>
-            <a:srgbClr val="FCE3D2"/>
+            <a:srgbClr val="4A3F4D"/>
           </a:solidFill>
           <a:ln/>
         </p:spPr>
@@ -8878,7 +8878,7 @@
             <a:r>
               <a:rPr lang="en-US" sz="2400" i="1" dirty="0">
                 <a:solidFill>
-                  <a:srgbClr val="2E2A3A"/>
+                  <a:srgbClr val="FBFAF4"/>
                 </a:solidFill>
                 <a:latin typeface="Alexandria" pitchFamily="34" charset="0"/>
                 <a:ea typeface="Alexandria" pitchFamily="34" charset="-122"/>
@@ -8920,7 +8920,7 @@
             <a:r>
               <a:rPr lang="en-US" sz="2400" b="1" dirty="0">
                 <a:solidFill>
-                  <a:srgbClr val="2E2A3A"/>
+                  <a:srgbClr val="FBFAF4"/>
                 </a:solidFill>
                 <a:latin typeface="Alexandria" pitchFamily="34" charset="0"/>
                 <a:ea typeface="Alexandria" pitchFamily="34" charset="-122"/>
@@ -8949,7 +8949,7 @@
             </a:avLst>
           </a:prstGeom>
           <a:solidFill>
-            <a:srgbClr val="CBE8F1"/>
+            <a:srgbClr val="144068"/>
           </a:solidFill>
           <a:ln/>
         </p:spPr>
@@ -9001,7 +9001,7 @@
             <a:r>
               <a:rPr lang="en-US" sz="2600" b="1" dirty="0">
                 <a:solidFill>
-                  <a:srgbClr val="2E2A3A"/>
+                  <a:srgbClr val="172849"/>
                 </a:solidFill>
                 <a:latin typeface="Alexandria" pitchFamily="34" charset="0"/>
                 <a:ea typeface="Alexandria" pitchFamily="34" charset="-122"/>
@@ -9043,7 +9043,7 @@
             <a:r>
               <a:rPr lang="en-US" sz="2400" dirty="0">
                 <a:solidFill>
-                  <a:srgbClr val="2E2A3A"/>
+                  <a:srgbClr val="FBFAF4"/>
                 </a:solidFill>
                 <a:latin typeface="Alexandria" pitchFamily="34" charset="0"/>
                 <a:ea typeface="Alexandria" pitchFamily="34" charset="-122"/>
@@ -9072,7 +9072,7 @@
             </a:avLst>
           </a:prstGeom>
           <a:solidFill>
-            <a:srgbClr val="FCE5D5"/>
+            <a:srgbClr val="453D4C"/>
           </a:solidFill>
           <a:ln/>
         </p:spPr>
@@ -9124,7 +9124,7 @@
             <a:r>
               <a:rPr lang="en-US" sz="2600" b="1" dirty="0">
                 <a:solidFill>
-                  <a:srgbClr val="2E2A3A"/>
+                  <a:srgbClr val="172849"/>
                 </a:solidFill>
                 <a:latin typeface="Alexandria" pitchFamily="34" charset="0"/>
                 <a:ea typeface="Alexandria" pitchFamily="34" charset="-122"/>
@@ -9166,7 +9166,7 @@
             <a:r>
               <a:rPr lang="en-US" sz="2400" dirty="0">
                 <a:solidFill>
-                  <a:srgbClr val="2E2A3A"/>
+                  <a:srgbClr val="FBFAF4"/>
                 </a:solidFill>
                 <a:latin typeface="Alexandria" pitchFamily="34" charset="0"/>
                 <a:ea typeface="Alexandria" pitchFamily="34" charset="-122"/>
@@ -9195,7 +9195,7 @@
             </a:avLst>
           </a:prstGeom>
           <a:solidFill>
-            <a:srgbClr val="E7D1DC"/>
+            <a:srgbClr val="302953"/>
           </a:solidFill>
           <a:ln/>
         </p:spPr>
@@ -9289,7 +9289,7 @@
             <a:r>
               <a:rPr lang="en-US" sz="2400" dirty="0">
                 <a:solidFill>
-                  <a:srgbClr val="2E2A3A"/>
+                  <a:srgbClr val="FBFAF4"/>
                 </a:solidFill>
                 <a:latin typeface="Alexandria" pitchFamily="34" charset="0"/>
                 <a:ea typeface="Alexandria" pitchFamily="34" charset="-122"/>
@@ -9318,7 +9318,7 @@
             </a:avLst>
           </a:prstGeom>
           <a:solidFill>
-            <a:srgbClr val="FCF2CF"/>
+            <a:srgbClr val="454A46"/>
           </a:solidFill>
           <a:ln/>
         </p:spPr>
@@ -9370,7 +9370,7 @@
             <a:r>
               <a:rPr lang="en-US" sz="2600" b="1" dirty="0">
                 <a:solidFill>
-                  <a:srgbClr val="2E2A3A"/>
+                  <a:srgbClr val="172849"/>
                 </a:solidFill>
                 <a:latin typeface="Alexandria" pitchFamily="34" charset="0"/>
                 <a:ea typeface="Alexandria" pitchFamily="34" charset="-122"/>
@@ -9412,7 +9412,7 @@
             <a:r>
               <a:rPr lang="en-US" sz="2400" dirty="0">
                 <a:solidFill>
-                  <a:srgbClr val="2E2A3A"/>
+                  <a:srgbClr val="FBFAF4"/>
                 </a:solidFill>
                 <a:latin typeface="Alexandria" pitchFamily="34" charset="0"/>
                 <a:ea typeface="Alexandria" pitchFamily="34" charset="-122"/>
@@ -9544,7 +9544,7 @@
             <a:r>
               <a:rPr lang="en-US" sz="2400" b="1" dirty="0">
                 <a:solidFill>
-                  <a:srgbClr val="2E2A3A"/>
+                  <a:srgbClr val="172849"/>
                 </a:solidFill>
                 <a:latin typeface="Alexandria" pitchFamily="34" charset="0"/>
                 <a:ea typeface="Alexandria" pitchFamily="34" charset="-122"/>
@@ -9564,7 +9564,7 @@
             <a:r>
               <a:rPr lang="en-US" sz="3600" b="1" dirty="0">
                 <a:solidFill>
-                  <a:srgbClr val="2E2A3A"/>
+                  <a:srgbClr val="172849"/>
                 </a:solidFill>
                 <a:latin typeface="Alexandria" pitchFamily="34" charset="0"/>
                 <a:ea typeface="Alexandria" pitchFamily="34" charset="-122"/>
@@ -9606,7 +9606,7 @@
             <a:r>
               <a:rPr lang="en-US" sz="3000" b="1" dirty="0">
                 <a:solidFill>
-                  <a:srgbClr val="2E2A3A"/>
+                  <a:srgbClr val="FBFAF4"/>
                 </a:solidFill>
                 <a:latin typeface="Alexandria" pitchFamily="34" charset="0"/>
                 <a:ea typeface="Alexandria" pitchFamily="34" charset="-122"/>
@@ -9635,7 +9635,7 @@
             </a:avLst>
           </a:prstGeom>
           <a:solidFill>
-            <a:srgbClr val="FCE5D5"/>
+            <a:srgbClr val="453D4C"/>
           </a:solidFill>
           <a:ln/>
         </p:spPr>
@@ -9687,7 +9687,7 @@
             <a:r>
               <a:rPr lang="en-US" sz="2600" b="1" dirty="0">
                 <a:solidFill>
-                  <a:srgbClr val="2E2A3A"/>
+                  <a:srgbClr val="172849"/>
                 </a:solidFill>
                 <a:latin typeface="Alexandria" pitchFamily="34" charset="0"/>
                 <a:ea typeface="Alexandria" pitchFamily="34" charset="-122"/>
@@ -9729,7 +9729,7 @@
             <a:r>
               <a:rPr lang="en-US" sz="3000" dirty="0">
                 <a:solidFill>
-                  <a:srgbClr val="2E2A3A"/>
+                  <a:srgbClr val="FBFAF4"/>
                 </a:solidFill>
                 <a:latin typeface="Alexandria" pitchFamily="34" charset="0"/>
                 <a:ea typeface="Alexandria" pitchFamily="34" charset="-122"/>
@@ -9758,7 +9758,7 @@
             </a:avLst>
           </a:prstGeom>
           <a:solidFill>
-            <a:srgbClr val="E7D1DC"/>
+            <a:srgbClr val="302953"/>
           </a:solidFill>
           <a:ln/>
         </p:spPr>
@@ -9852,7 +9852,7 @@
             <a:r>
               <a:rPr lang="en-US" sz="3000" dirty="0">
                 <a:solidFill>
-                  <a:srgbClr val="2E2A3A"/>
+                  <a:srgbClr val="FBFAF4"/>
                 </a:solidFill>
                 <a:latin typeface="Alexandria" pitchFamily="34" charset="0"/>
                 <a:ea typeface="Alexandria" pitchFamily="34" charset="-122"/>
@@ -9881,7 +9881,7 @@
             </a:avLst>
           </a:prstGeom>
           <a:solidFill>
-            <a:srgbClr val="FCF2CF"/>
+            <a:srgbClr val="454A46"/>
           </a:solidFill>
           <a:ln/>
         </p:spPr>
@@ -9933,7 +9933,7 @@
             <a:r>
               <a:rPr lang="en-US" sz="2600" b="1" dirty="0">
                 <a:solidFill>
-                  <a:srgbClr val="2E2A3A"/>
+                  <a:srgbClr val="172849"/>
                 </a:solidFill>
                 <a:latin typeface="Alexandria" pitchFamily="34" charset="0"/>
                 <a:ea typeface="Alexandria" pitchFamily="34" charset="-122"/>
@@ -9975,7 +9975,7 @@
             <a:r>
               <a:rPr lang="en-US" sz="3000" dirty="0">
                 <a:solidFill>
-                  <a:srgbClr val="2E2A3A"/>
+                  <a:srgbClr val="FBFAF4"/>
                 </a:solidFill>
                 <a:latin typeface="Alexandria" pitchFamily="34" charset="0"/>
                 <a:ea typeface="Alexandria" pitchFamily="34" charset="-122"/>
@@ -10004,7 +10004,7 @@
             </a:avLst>
           </a:prstGeom>
           <a:solidFill>
-            <a:srgbClr val="D7ECE1"/>
+            <a:srgbClr val="214458"/>
           </a:solidFill>
           <a:ln/>
         </p:spPr>
@@ -10056,7 +10056,7 @@
             <a:r>
               <a:rPr lang="en-US" sz="2600" b="1" dirty="0">
                 <a:solidFill>
-                  <a:srgbClr val="2E2A3A"/>
+                  <a:srgbClr val="172849"/>
                 </a:solidFill>
                 <a:latin typeface="Alexandria" pitchFamily="34" charset="0"/>
                 <a:ea typeface="Alexandria" pitchFamily="34" charset="-122"/>
@@ -10098,7 +10098,7 @@
             <a:r>
               <a:rPr lang="en-US" sz="3000" dirty="0">
                 <a:solidFill>
-                  <a:srgbClr val="2E2A3A"/>
+                  <a:srgbClr val="FBFAF4"/>
                 </a:solidFill>
                 <a:latin typeface="Alexandria" pitchFamily="34" charset="0"/>
                 <a:ea typeface="Alexandria" pitchFamily="34" charset="-122"/>
@@ -10230,7 +10230,7 @@
             <a:r>
               <a:rPr lang="en-US" sz="2400" b="1" dirty="0">
                 <a:solidFill>
-                  <a:srgbClr val="2E2A3A"/>
+                  <a:srgbClr val="172849"/>
                 </a:solidFill>
                 <a:latin typeface="Alexandria" pitchFamily="34" charset="0"/>
                 <a:ea typeface="Alexandria" pitchFamily="34" charset="-122"/>
@@ -10250,7 +10250,7 @@
             <a:r>
               <a:rPr lang="en-US" sz="3600" b="1" dirty="0">
                 <a:solidFill>
-                  <a:srgbClr val="2E2A3A"/>
+                  <a:srgbClr val="172849"/>
                 </a:solidFill>
                 <a:latin typeface="Alexandria" pitchFamily="34" charset="0"/>
                 <a:ea typeface="Alexandria" pitchFamily="34" charset="-122"/>
@@ -10292,7 +10292,7 @@
             <a:r>
               <a:rPr lang="en-US" sz="2800" b="1" dirty="0">
                 <a:solidFill>
-                  <a:srgbClr val="2E2A3A"/>
+                  <a:srgbClr val="FBFAF4"/>
                 </a:solidFill>
                 <a:latin typeface="Alexandria" pitchFamily="34" charset="0"/>
                 <a:ea typeface="Alexandria" pitchFamily="34" charset="-122"/>
@@ -10321,7 +10321,7 @@
             </a:avLst>
           </a:prstGeom>
           <a:solidFill>
-            <a:srgbClr val="E7D1DC"/>
+            <a:srgbClr val="302953"/>
           </a:solidFill>
           <a:ln/>
         </p:spPr>
@@ -10415,7 +10415,7 @@
             <a:r>
               <a:rPr lang="en-US" sz="2800" dirty="0">
                 <a:solidFill>
-                  <a:srgbClr val="2E2A3A"/>
+                  <a:srgbClr val="FBFAF4"/>
                 </a:solidFill>
                 <a:latin typeface="Alexandria" pitchFamily="34" charset="0"/>
                 <a:ea typeface="Alexandria" pitchFamily="34" charset="-122"/>
@@ -10444,7 +10444,7 @@
             </a:avLst>
           </a:prstGeom>
           <a:solidFill>
-            <a:srgbClr val="FCF2CF"/>
+            <a:srgbClr val="454A46"/>
           </a:solidFill>
           <a:ln/>
         </p:spPr>
@@ -10496,7 +10496,7 @@
             <a:r>
               <a:rPr lang="en-US" sz="2600" b="1" dirty="0">
                 <a:solidFill>
-                  <a:srgbClr val="2E2A3A"/>
+                  <a:srgbClr val="172849"/>
                 </a:solidFill>
                 <a:latin typeface="Alexandria" pitchFamily="34" charset="0"/>
                 <a:ea typeface="Alexandria" pitchFamily="34" charset="-122"/>
@@ -10538,7 +10538,7 @@
             <a:r>
               <a:rPr lang="en-US" sz="2800" dirty="0">
                 <a:solidFill>
-                  <a:srgbClr val="2E2A3A"/>
+                  <a:srgbClr val="FBFAF4"/>
                 </a:solidFill>
                 <a:latin typeface="Alexandria" pitchFamily="34" charset="0"/>
                 <a:ea typeface="Alexandria" pitchFamily="34" charset="-122"/>
@@ -10567,7 +10567,7 @@
             </a:avLst>
           </a:prstGeom>
           <a:solidFill>
-            <a:srgbClr val="D7ECE1"/>
+            <a:srgbClr val="214458"/>
           </a:solidFill>
           <a:ln/>
         </p:spPr>
@@ -10619,7 +10619,7 @@
             <a:r>
               <a:rPr lang="en-US" sz="2600" b="1" dirty="0">
                 <a:solidFill>
-                  <a:srgbClr val="2E2A3A"/>
+                  <a:srgbClr val="172849"/>
                 </a:solidFill>
                 <a:latin typeface="Alexandria" pitchFamily="34" charset="0"/>
                 <a:ea typeface="Alexandria" pitchFamily="34" charset="-122"/>
@@ -10661,7 +10661,7 @@
             <a:r>
               <a:rPr lang="en-US" sz="2800" dirty="0">
                 <a:solidFill>
-                  <a:srgbClr val="2E2A3A"/>
+                  <a:srgbClr val="FBFAF4"/>
                 </a:solidFill>
                 <a:latin typeface="Alexandria" pitchFamily="34" charset="0"/>
                 <a:ea typeface="Alexandria" pitchFamily="34" charset="-122"/>
@@ -10690,7 +10690,7 @@
             </a:avLst>
           </a:prstGeom>
           <a:solidFill>
-            <a:srgbClr val="FCD8DB"/>
+            <a:srgbClr val="453052"/>
           </a:solidFill>
           <a:ln/>
         </p:spPr>
@@ -10742,7 +10742,7 @@
             <a:r>
               <a:rPr lang="en-US" sz="2600" b="1" dirty="0">
                 <a:solidFill>
-                  <a:srgbClr val="2E2A3A"/>
+                  <a:srgbClr val="172849"/>
                 </a:solidFill>
                 <a:latin typeface="Alexandria" pitchFamily="34" charset="0"/>
                 <a:ea typeface="Alexandria" pitchFamily="34" charset="-122"/>
@@ -10784,7 +10784,7 @@
             <a:r>
               <a:rPr lang="en-US" sz="2800" dirty="0">
                 <a:solidFill>
-                  <a:srgbClr val="2E2A3A"/>
+                  <a:srgbClr val="FBFAF4"/>
                 </a:solidFill>
                 <a:latin typeface="Alexandria" pitchFamily="34" charset="0"/>
                 <a:ea typeface="Alexandria" pitchFamily="34" charset="-122"/>
@@ -10978,7 +10978,7 @@
             <a:r>
               <a:rPr lang="en-US" sz="3000" b="1" dirty="0">
                 <a:solidFill>
-                  <a:srgbClr val="2E2A3A"/>
+                  <a:srgbClr val="FBFAF4"/>
                 </a:solidFill>
                 <a:latin typeface="Alexandria" pitchFamily="34" charset="0"/>
                 <a:ea typeface="Alexandria" pitchFamily="34" charset="-122"/>
@@ -11007,7 +11007,7 @@
             </a:avLst>
           </a:prstGeom>
           <a:solidFill>
-            <a:srgbClr val="FCF2CF"/>
+            <a:srgbClr val="454A46"/>
           </a:solidFill>
           <a:ln/>
         </p:spPr>
@@ -11059,7 +11059,7 @@
             <a:r>
               <a:rPr lang="en-US" sz="2600" b="1" dirty="0">
                 <a:solidFill>
-                  <a:srgbClr val="2E2A3A"/>
+                  <a:srgbClr val="172849"/>
                 </a:solidFill>
                 <a:latin typeface="Alexandria" pitchFamily="34" charset="0"/>
                 <a:ea typeface="Alexandria" pitchFamily="34" charset="-122"/>
@@ -11101,7 +11101,7 @@
             <a:r>
               <a:rPr lang="en-US" sz="3000" dirty="0">
                 <a:solidFill>
-                  <a:srgbClr val="2E2A3A"/>
+                  <a:srgbClr val="FBFAF4"/>
                 </a:solidFill>
                 <a:latin typeface="Alexandria" pitchFamily="34" charset="0"/>
                 <a:ea typeface="Alexandria" pitchFamily="34" charset="-122"/>
@@ -11130,7 +11130,7 @@
             </a:avLst>
           </a:prstGeom>
           <a:solidFill>
-            <a:srgbClr val="D7ECE1"/>
+            <a:srgbClr val="214458"/>
           </a:solidFill>
           <a:ln/>
         </p:spPr>
@@ -11182,7 +11182,7 @@
             <a:r>
               <a:rPr lang="en-US" sz="2600" b="1" dirty="0">
                 <a:solidFill>
-                  <a:srgbClr val="2E2A3A"/>
+                  <a:srgbClr val="172849"/>
                 </a:solidFill>
                 <a:latin typeface="Alexandria" pitchFamily="34" charset="0"/>
                 <a:ea typeface="Alexandria" pitchFamily="34" charset="-122"/>
@@ -11224,7 +11224,7 @@
             <a:r>
               <a:rPr lang="en-US" sz="3000" dirty="0">
                 <a:solidFill>
-                  <a:srgbClr val="2E2A3A"/>
+                  <a:srgbClr val="FBFAF4"/>
                 </a:solidFill>
                 <a:latin typeface="Alexandria" pitchFamily="34" charset="0"/>
                 <a:ea typeface="Alexandria" pitchFamily="34" charset="-122"/>
@@ -11253,7 +11253,7 @@
             </a:avLst>
           </a:prstGeom>
           <a:solidFill>
-            <a:srgbClr val="FCD8DB"/>
+            <a:srgbClr val="453052"/>
           </a:solidFill>
           <a:ln/>
         </p:spPr>
@@ -11305,7 +11305,7 @@
             <a:r>
               <a:rPr lang="en-US" sz="2600" b="1" dirty="0">
                 <a:solidFill>
-                  <a:srgbClr val="2E2A3A"/>
+                  <a:srgbClr val="172849"/>
                 </a:solidFill>
                 <a:latin typeface="Alexandria" pitchFamily="34" charset="0"/>
                 <a:ea typeface="Alexandria" pitchFamily="34" charset="-122"/>
@@ -11347,7 +11347,7 @@
             <a:r>
               <a:rPr lang="en-US" sz="3000" dirty="0">
                 <a:solidFill>
-                  <a:srgbClr val="2E2A3A"/>
+                  <a:srgbClr val="FBFAF4"/>
                 </a:solidFill>
                 <a:latin typeface="Alexandria" pitchFamily="34" charset="0"/>
                 <a:ea typeface="Alexandria" pitchFamily="34" charset="-122"/>
@@ -11376,7 +11376,7 @@
             </a:avLst>
           </a:prstGeom>
           <a:solidFill>
-            <a:srgbClr val="CBE8F1"/>
+            <a:srgbClr val="144068"/>
           </a:solidFill>
           <a:ln/>
         </p:spPr>
@@ -11428,7 +11428,7 @@
             <a:r>
               <a:rPr lang="en-US" sz="2600" b="1" dirty="0">
                 <a:solidFill>
-                  <a:srgbClr val="2E2A3A"/>
+                  <a:srgbClr val="172849"/>
                 </a:solidFill>
                 <a:latin typeface="Alexandria" pitchFamily="34" charset="0"/>
                 <a:ea typeface="Alexandria" pitchFamily="34" charset="-122"/>
@@ -11470,7 +11470,7 @@
             <a:r>
               <a:rPr lang="en-US" sz="3000" dirty="0">
                 <a:solidFill>
-                  <a:srgbClr val="2E2A3A"/>
+                  <a:srgbClr val="FBFAF4"/>
                 </a:solidFill>
                 <a:latin typeface="Alexandria" pitchFamily="34" charset="0"/>
                 <a:ea typeface="Alexandria" pitchFamily="34" charset="-122"/>
@@ -11498,7 +11498,7 @@
   <a:themeElements>
     <a:clrScheme name="MKT1107">
       <a:dk1>
-        <a:srgbClr val="2E2A3A"/>
+        <a:srgbClr val="FBFAF4"/>
       </a:dk1>
       <a:lt1>
         <a:srgbClr val="FFFFFF"/>
@@ -11507,7 +11507,7 @@
         <a:srgbClr val="962B7C"/>
       </a:dk2>
       <a:lt2>
-        <a:srgbClr val="FBFAF4"/>
+        <a:srgbClr val="172849"/>
       </a:lt2>
       <a:accent1>
         <a:srgbClr val="49B296"/>

</xml_diff>